<commit_message>
CHECKPOINT: Proposal skill updates plus GITA, Avita, Elplus, Make, MBC, and Pasha Bank materials
Co-authored-by: Cursor <cursoragent@cursor.com>
</commit_message>
<xml_diff>
--- a/GITA/Pre-Acceleration/2026-5h-AI-for-Startups/day2-slides.pptx
+++ b/GITA/Pre-Acceleration/2026-5h-AI-for-Startups/day2-slides.pptx
@@ -33344,7 +33344,7 @@
                 <a:cs typeface="Consolas"/>
                 <a:latin typeface="Consolas"/>
               </a:rPr>
-              <a:t>"gemini-1.5-flash",</a:t>
+              <a:t>"gemini-flash",</a:t>
             </a:r>
           </a:p>
           <a:p>
@@ -51528,7 +51528,7 @@
                 <a:cs typeface="Sylfaen"/>
                 <a:latin typeface="Sylfaen"/>
               </a:rPr>
-              <a:t>შენ ხარ წამყვანი ქოპირაიტერი, რომელიც სპეციალიზებულია ტექნოლოგიური სტარტაპების სარეკლამო კამპანიებზე. ჩემი სტარტაპია: [მაგალითად: Compliance Copilot - AI-ასისტენტი ფინანსური ორგანიზაციებისთვის AML/CFT პროცესების ავტომატიზაციისთვის]. დამიწერე სარეკლამო მასალები შემდეგი ფორმატით: 1. **Landing Page-ის Hero Section ტექსტი:** - 1 მიმზიდველი სათაური (Hook / UVP) - 1 დამხმარე ქვესათაური (Sub-headline) - 1 მკაფიო მოქმედებისკენ მოწოდება (Call to Action - CTA) 2. **AIDA მოდელის Facebook პოსტი (Attention, Interest, Desire, Action):** - შექმენი პოსტი, რომელიც მიიპყრობს ყურადღებას პირველივე ხაზით, გააღვიძებს ინტერესს ფაქტებით, აღძრავს სურვილს სარგებლით და მოუწოდებს დარეგისტრირებისკენ. 3. **PAS მოდელის LinkedIn პოსტი (Problem, Agitate, Solve):** - შექმენი პოსტი B2B აუდიტორიისთვის, რომელიც იწყება რეალური ბიზნეს-ტკივილით (Compliance რუტინა, ჯარიმების რისკი), ამძაფრებს მას ემოციურად/ფინანსურად და ბოლოს სთავაზობს Compliance Copilot-ს, როგორც მარტივ ხსნას. ტონი შეინარჩუნე ბიზნეს-კომპეტენტური, მაგრამ თანამედროვე. გამოიყენე ემოჯიები ზომიერად.</a:t>
+              <a:t>შენ ხარ წამყვანი ქოპირაიტერი, რომელიც სპეციალიზებულია ტექნოლოგიური სტარტაპების სარეკლამო კამპანიებზე. ჩემი სტარტაპია: [მაგალითად: Flexi - ციფრული ინფრასტრუქტურა და marketplace ფიტნეს დარბაზებისთვის (ავტომატური გადახდები და წევრების შენარჩუნება)]. დამიწერე სარეკლამო მასალები შემდეგი ფორმატით: 1. **Landing Page-ის Hero Section ტექსტი:** - 1 მიმზიდველი სათაური (Hook / UVP) - 1 დამხმარე ქვესათაური (Sub-headline) - 1 მკაფიო მოქმედებისკენ მოწოდება (Call to Action - CTA) 2. **AIDA მოდელის Facebook პოსტი (Attention, Interest, Desire, Action):** - შექმენი პოსტი, რომელიც მიიპყრობს ყურადღებას პირველივე ხაზით, გააღვიძებს ინტერესს ფაქტებით, აღძრავს სურვილს სარგებლით და მოუწოდებს დარეგისტრირებისკენ. 3. **PAS მოდელის LinkedIn პოსტი (Problem, Agitate, Solve):** - შექმენი პოსტი დარბაზების მფლობელებისთვის, რომელიც იწყება რეალური ბიზნეს-ტკივილით (გადაუხდელი აბონემენტები, წევრების ჩუმი გადინება და ხელით რვეულში ჩაწერა), ამძაფრებს მას დაკარგული შემოსავლის კუთხით და ბოლოს სთავაზობს Flexi-ს, როგორც მარტივ ავტომატურ გადაწყვეტას. ტონი შეინარჩუნე ბიზნეს-კომპეტენტური, მაგრამ თანამედროვე. გამოიყენე ემოჯიები ზომიერად.</a:t>
             </a:r>
           </a:p>
         </p:txBody>

</xml_diff>